<commit_message>
Run Q2 notebook: results, charts, conclusions; update slides with real numbers
Co-Authored-By: Claude Opus 5.5 <noreply@anthropic.com>
Claude-Session: https://claude.ai/code/session_01Dodtt6SYgFo6Peocx728t9
</commit_message>
<xml_diff>
--- a/Presentation/ICT304_Tutorial3_Group4_DRAFT.pptx
+++ b/Presentation/ICT304_Tutorial3_Group4_DRAFT.pptx
@@ -672,7 +672,7 @@
           <a:lstStyle/>
           <a:p>
             <a:r>
-              <a:t>Fill in the exact numbers from the notebook's final cell before presenting.</a:t>
+              <a:t>Numbers are from the test set (835 abalone, 73 old). Point at the 'found' column: logistic regression goes from finding 13 old abalone to 58. Then be honest about the cost: 107 false alarms. Finish with the PR-AUC point — the fixes move the decision point, they don't make the model smarter.</a:t>
             </a:r>
           </a:p>
         </p:txBody>
@@ -6062,7 +6062,7 @@
           <a:bodyPr rtlCol="0" anchor="ctr" wrap="square" lIns="182880"/>
           <a:lstStyle/>
           <a:p>
-            <a:pPr algn="ctr"/>
+            <a:pPr algn="l"/>
             <a:r>
               <a:rPr sz="1200">
                 <a:solidFill>
@@ -6070,13 +6070,79 @@
                 </a:solidFill>
                 <a:latin typeface="Menlo"/>
               </a:rPr>
-              <a:t>pipe = Pipeline([
-    ("prep", ColumnTransformer([("sex", OneHotEncoder(), ["Sex"]),
-                                 ("num", StandardScaler(), numeric_cols)])),
-    ("resample", SMOTE(random_state=42)),      # only runs during fit()
-    ("model", LogisticRegression(max_iter=2000)),
-])
-pipe.fit(X_train, y_train)    # test set is never resampled</a:t>
+              <a:t>pipe = Pipeline([</a:t>
+            </a:r>
+          </a:p>
+          <a:p>
+            <a:pPr algn="l"/>
+            <a:r>
+              <a:rPr sz="1200">
+                <a:solidFill>
+                  <a:srgbClr val="D4D4D4"/>
+                </a:solidFill>
+                <a:latin typeface="Menlo"/>
+              </a:rPr>
+              <a:t>    ("prep", ColumnTransformer([("sex", OneHotEncoder(), ["Sex"]),</a:t>
+            </a:r>
+          </a:p>
+          <a:p>
+            <a:pPr algn="l"/>
+            <a:r>
+              <a:rPr sz="1200">
+                <a:solidFill>
+                  <a:srgbClr val="D4D4D4"/>
+                </a:solidFill>
+                <a:latin typeface="Menlo"/>
+              </a:rPr>
+              <a:t>                                 ("num", StandardScaler(), numeric_cols)])),</a:t>
+            </a:r>
+          </a:p>
+          <a:p>
+            <a:pPr algn="l"/>
+            <a:r>
+              <a:rPr sz="1200">
+                <a:solidFill>
+                  <a:srgbClr val="D4D4D4"/>
+                </a:solidFill>
+                <a:latin typeface="Menlo"/>
+              </a:rPr>
+              <a:t>    ("resample", SMOTE(random_state=42)),      # only runs during fit()</a:t>
+            </a:r>
+          </a:p>
+          <a:p>
+            <a:pPr algn="l"/>
+            <a:r>
+              <a:rPr sz="1200">
+                <a:solidFill>
+                  <a:srgbClr val="D4D4D4"/>
+                </a:solidFill>
+                <a:latin typeface="Menlo"/>
+              </a:rPr>
+              <a:t>    ("model", LogisticRegression(max_iter=2000)),</a:t>
+            </a:r>
+          </a:p>
+          <a:p>
+            <a:pPr algn="l"/>
+            <a:r>
+              <a:rPr sz="1200">
+                <a:solidFill>
+                  <a:srgbClr val="D4D4D4"/>
+                </a:solidFill>
+                <a:latin typeface="Menlo"/>
+              </a:rPr>
+              <a:t>])</a:t>
+            </a:r>
+          </a:p>
+          <a:p>
+            <a:pPr algn="l"/>
+            <a:r>
+              <a:rPr sz="1200">
+                <a:solidFill>
+                  <a:srgbClr val="D4D4D4"/>
+                </a:solidFill>
+                <a:latin typeface="Menlo"/>
+              </a:rPr>
+              <a:t>pipe.fit(X_train, y_train)    # test set is never resampled</a:t>
             </a:r>
           </a:p>
         </p:txBody>
@@ -6705,62 +6771,30 @@
           </a:graphicData>
         </a:graphic>
       </p:graphicFrame>
-      <p:sp>
-        <p:nvSpPr>
-          <p:cNvPr id="8" name="Rounded Rectangle 7"/>
-          <p:cNvSpPr/>
+      <p:pic>
+        <p:nvPicPr>
+          <p:cNvPr id="8" name="Picture 7" descr="fig3_resampled_counts.png"/>
+          <p:cNvPicPr>
+            <a:picLocks noChangeAspect="1"/>
+          </p:cNvPicPr>
           <p:nvPr/>
-        </p:nvSpPr>
+        </p:nvPicPr>
+        <p:blipFill>
+          <a:blip r:embed="rId3"/>
+          <a:stretch>
+            <a:fillRect/>
+          </a:stretch>
+        </p:blipFill>
         <p:spPr>
           <a:xfrm>
             <a:off x="8046720" y="1280160"/>
-            <a:ext cx="3931920" cy="2743200"/>
-          </a:xfrm>
-          <a:prstGeom prst="roundRect">
-            <a:avLst>
-              <a:gd name="adj" fmla="val 8000"/>
-            </a:avLst>
+            <a:ext cx="3931920" cy="1700290"/>
+          </a:xfrm>
+          <a:prstGeom prst="rect">
+            <a:avLst/>
           </a:prstGeom>
-          <a:solidFill>
-            <a:srgbClr val="FDEDEC"/>
-          </a:solidFill>
-          <a:ln>
-            <a:solidFill>
-              <a:srgbClr val="2E86C1"/>
-            </a:solidFill>
-          </a:ln>
-        </p:spPr>
-        <p:style>
-          <a:lnRef idx="1">
-            <a:schemeClr val="accent1"/>
-          </a:lnRef>
-          <a:fillRef idx="3">
-            <a:schemeClr val="accent1"/>
-          </a:fillRef>
-          <a:effectRef idx="2">
-            <a:schemeClr val="accent1"/>
-          </a:effectRef>
-          <a:fontRef idx="minor">
-            <a:schemeClr val="lt1"/>
-          </a:fontRef>
-        </p:style>
-        <p:txBody>
-          <a:bodyPr rtlCol="0" anchor="ctr" wrap="square" lIns="137160" rIns="137160"/>
-          <a:lstStyle/>
-          <a:p>
-            <a:pPr algn="l"/>
-            <a:r>
-              <a:rPr sz="1600">
-                <a:solidFill>
-                  <a:srgbClr val="C0392B"/>
-                </a:solidFill>
-                <a:latin typeface="Calibri"/>
-              </a:rPr>
-              <a:t>[Figure missing: fig3_resampled_counts.png — run the notebook]</a:t>
-            </a:r>
-          </a:p>
-        </p:txBody>
-      </p:sp>
+        </p:spPr>
+      </p:pic>
       <p:sp>
         <p:nvSpPr>
           <p:cNvPr id="9" name="Rounded Rectangle 8"/>
@@ -7018,118 +7052,841 @@
           </a:p>
         </p:txBody>
       </p:sp>
-      <p:sp>
-        <p:nvSpPr>
-          <p:cNvPr id="7" name="Rounded Rectangle 6"/>
-          <p:cNvSpPr/>
+      <p:graphicFrame>
+        <p:nvGraphicFramePr>
+          <p:cNvPr id="7" name="Table 6"/>
+          <p:cNvGraphicFramePr>
+            <a:graphicFrameLocks noGrp="1"/>
+          </p:cNvGraphicFramePr>
           <p:nvPr/>
-        </p:nvSpPr>
-        <p:spPr>
-          <a:xfrm>
-            <a:off x="365760" y="1280160"/>
-            <a:ext cx="11430000" cy="2286000"/>
-          </a:xfrm>
-          <a:prstGeom prst="roundRect">
-            <a:avLst>
-              <a:gd name="adj" fmla="val 8000"/>
-            </a:avLst>
+        </p:nvGraphicFramePr>
+        <p:xfrm>
+          <a:off x="365760" y="1234440"/>
+          <a:ext cx="11430000" cy="2743200"/>
+        </p:xfrm>
+        <a:graphic>
+          <a:graphicData uri="http://schemas.openxmlformats.org/drawingml/2006/table">
+            <a:tbl>
+              <a:tblPr firstRow="1" bandRow="1">
+                <a:tableStyleId>{5C22544A-7EE6-4342-B048-85BDC9FD1C3A}</a:tableStyleId>
+              </a:tblPr>
+              <a:tblGrid>
+                <a:gridCol w="3810000"/>
+                <a:gridCol w="1270000"/>
+                <a:gridCol w="1270000"/>
+                <a:gridCol w="1270000"/>
+                <a:gridCol w="1270000"/>
+                <a:gridCol w="1270000"/>
+                <a:gridCol w="1270000"/>
+              </a:tblGrid>
+              <a:tr h="548640">
+                <a:tc>
+                  <a:txBody>
+                    <a:bodyPr wrap="square"/>
+                    <a:lstStyle/>
+                    <a:p>
+                      <a:r>
+                        <a:rPr sz="1400" b="1">
+                          <a:solidFill>
+                            <a:srgbClr val="FFFFFF"/>
+                          </a:solidFill>
+                          <a:latin typeface="Calibri"/>
+                        </a:rPr>
+                        <a:t>Model / method</a:t>
+                      </a:r>
+                    </a:p>
+                  </a:txBody>
+                  <a:tcPr marL="54864" marR="54864" marT="27432" marB="27432">
+                    <a:solidFill>
+                      <a:srgbClr val="2E86C1"/>
+                    </a:solidFill>
+                  </a:tcPr>
+                </a:tc>
+                <a:tc>
+                  <a:txBody>
+                    <a:bodyPr wrap="square"/>
+                    <a:lstStyle/>
+                    <a:p>
+                      <a:r>
+                        <a:rPr sz="1400" b="1">
+                          <a:solidFill>
+                            <a:srgbClr val="FFFFFF"/>
+                          </a:solidFill>
+                          <a:latin typeface="Calibri"/>
+                        </a:rPr>
+                        <a:t>Accuracy</a:t>
+                      </a:r>
+                    </a:p>
+                  </a:txBody>
+                  <a:tcPr marL="54864" marR="54864" marT="27432" marB="27432">
+                    <a:solidFill>
+                      <a:srgbClr val="2E86C1"/>
+                    </a:solidFill>
+                  </a:tcPr>
+                </a:tc>
+                <a:tc>
+                  <a:txBody>
+                    <a:bodyPr wrap="square"/>
+                    <a:lstStyle/>
+                    <a:p>
+                      <a:r>
+                        <a:rPr sz="1400" b="1">
+                          <a:solidFill>
+                            <a:srgbClr val="FFFFFF"/>
+                          </a:solidFill>
+                          <a:latin typeface="Calibri"/>
+                        </a:rPr>
+                        <a:t>Recall (old)</a:t>
+                      </a:r>
+                    </a:p>
+                  </a:txBody>
+                  <a:tcPr marL="54864" marR="54864" marT="27432" marB="27432">
+                    <a:solidFill>
+                      <a:srgbClr val="2E86C1"/>
+                    </a:solidFill>
+                  </a:tcPr>
+                </a:tc>
+                <a:tc>
+                  <a:txBody>
+                    <a:bodyPr wrap="square"/>
+                    <a:lstStyle/>
+                    <a:p>
+                      <a:r>
+                        <a:rPr sz="1400" b="1">
+                          <a:solidFill>
+                            <a:srgbClr val="FFFFFF"/>
+                          </a:solidFill>
+                          <a:latin typeface="Calibri"/>
+                        </a:rPr>
+                        <a:t>Precision (old)</a:t>
+                      </a:r>
+                    </a:p>
+                  </a:txBody>
+                  <a:tcPr marL="54864" marR="54864" marT="27432" marB="27432">
+                    <a:solidFill>
+                      <a:srgbClr val="2E86C1"/>
+                    </a:solidFill>
+                  </a:tcPr>
+                </a:tc>
+                <a:tc>
+                  <a:txBody>
+                    <a:bodyPr wrap="square"/>
+                    <a:lstStyle/>
+                    <a:p>
+                      <a:r>
+                        <a:rPr sz="1400" b="1">
+                          <a:solidFill>
+                            <a:srgbClr val="FFFFFF"/>
+                          </a:solidFill>
+                          <a:latin typeface="Calibri"/>
+                        </a:rPr>
+                        <a:t>F1 (old)</a:t>
+                      </a:r>
+                    </a:p>
+                  </a:txBody>
+                  <a:tcPr marL="54864" marR="54864" marT="27432" marB="27432">
+                    <a:solidFill>
+                      <a:srgbClr val="2E86C1"/>
+                    </a:solidFill>
+                  </a:tcPr>
+                </a:tc>
+                <a:tc>
+                  <a:txBody>
+                    <a:bodyPr wrap="square"/>
+                    <a:lstStyle/>
+                    <a:p>
+                      <a:r>
+                        <a:rPr sz="1400" b="1">
+                          <a:solidFill>
+                            <a:srgbClr val="FFFFFF"/>
+                          </a:solidFill>
+                          <a:latin typeface="Calibri"/>
+                        </a:rPr>
+                        <a:t>Balanced acc.</a:t>
+                      </a:r>
+                    </a:p>
+                  </a:txBody>
+                  <a:tcPr marL="54864" marR="54864" marT="27432" marB="27432">
+                    <a:solidFill>
+                      <a:srgbClr val="2E86C1"/>
+                    </a:solidFill>
+                  </a:tcPr>
+                </a:tc>
+                <a:tc>
+                  <a:txBody>
+                    <a:bodyPr wrap="square"/>
+                    <a:lstStyle/>
+                    <a:p>
+                      <a:r>
+                        <a:rPr sz="1400" b="1">
+                          <a:solidFill>
+                            <a:srgbClr val="FFFFFF"/>
+                          </a:solidFill>
+                          <a:latin typeface="Calibri"/>
+                        </a:rPr>
+                        <a:t>PR-AUC</a:t>
+                      </a:r>
+                    </a:p>
+                  </a:txBody>
+                  <a:tcPr marL="54864" marR="54864" marT="27432" marB="27432">
+                    <a:solidFill>
+                      <a:srgbClr val="2E86C1"/>
+                    </a:solidFill>
+                  </a:tcPr>
+                </a:tc>
+              </a:tr>
+              <a:tr h="548640">
+                <a:tc>
+                  <a:txBody>
+                    <a:bodyPr wrap="square"/>
+                    <a:lstStyle/>
+                    <a:p>
+                      <a:r>
+                        <a:rPr sz="1400" b="1">
+                          <a:solidFill>
+                            <a:srgbClr val="1B2A41"/>
+                          </a:solidFill>
+                          <a:latin typeface="Calibri"/>
+                        </a:rPr>
+                        <a:t>Logistic Regression — baseline</a:t>
+                      </a:r>
+                    </a:p>
+                  </a:txBody>
+                  <a:tcPr marL="54864" marR="54864" marT="27432" marB="27432">
+                    <a:solidFill>
+                      <a:srgbClr val="EEF3F8"/>
+                    </a:solidFill>
+                  </a:tcPr>
+                </a:tc>
+                <a:tc>
+                  <a:txBody>
+                    <a:bodyPr wrap="square"/>
+                    <a:lstStyle/>
+                    <a:p>
+                      <a:r>
+                        <a:rPr sz="1400" b="0">
+                          <a:solidFill>
+                            <a:srgbClr val="1B2A41"/>
+                          </a:solidFill>
+                          <a:latin typeface="Calibri"/>
+                        </a:rPr>
+                        <a:t>0.91</a:t>
+                      </a:r>
+                    </a:p>
+                  </a:txBody>
+                  <a:tcPr marL="54864" marR="54864" marT="27432" marB="27432">
+                    <a:solidFill>
+                      <a:srgbClr val="EEF3F8"/>
+                    </a:solidFill>
+                  </a:tcPr>
+                </a:tc>
+                <a:tc>
+                  <a:txBody>
+                    <a:bodyPr wrap="square"/>
+                    <a:lstStyle/>
+                    <a:p>
+                      <a:r>
+                        <a:rPr sz="1400" b="0">
+                          <a:solidFill>
+                            <a:srgbClr val="1B2A41"/>
+                          </a:solidFill>
+                          <a:latin typeface="Calibri"/>
+                        </a:rPr>
+                        <a:t>0.18</a:t>
+                      </a:r>
+                    </a:p>
+                  </a:txBody>
+                  <a:tcPr marL="54864" marR="54864" marT="27432" marB="27432">
+                    <a:solidFill>
+                      <a:srgbClr val="EEF3F8"/>
+                    </a:solidFill>
+                  </a:tcPr>
+                </a:tc>
+                <a:tc>
+                  <a:txBody>
+                    <a:bodyPr wrap="square"/>
+                    <a:lstStyle/>
+                    <a:p>
+                      <a:r>
+                        <a:rPr sz="1400" b="0">
+                          <a:solidFill>
+                            <a:srgbClr val="1B2A41"/>
+                          </a:solidFill>
+                          <a:latin typeface="Calibri"/>
+                        </a:rPr>
+                        <a:t>0.52</a:t>
+                      </a:r>
+                    </a:p>
+                  </a:txBody>
+                  <a:tcPr marL="54864" marR="54864" marT="27432" marB="27432">
+                    <a:solidFill>
+                      <a:srgbClr val="EEF3F8"/>
+                    </a:solidFill>
+                  </a:tcPr>
+                </a:tc>
+                <a:tc>
+                  <a:txBody>
+                    <a:bodyPr wrap="square"/>
+                    <a:lstStyle/>
+                    <a:p>
+                      <a:r>
+                        <a:rPr sz="1400" b="0">
+                          <a:solidFill>
+                            <a:srgbClr val="1B2A41"/>
+                          </a:solidFill>
+                          <a:latin typeface="Calibri"/>
+                        </a:rPr>
+                        <a:t>0.27</a:t>
+                      </a:r>
+                    </a:p>
+                  </a:txBody>
+                  <a:tcPr marL="54864" marR="54864" marT="27432" marB="27432">
+                    <a:solidFill>
+                      <a:srgbClr val="EEF3F8"/>
+                    </a:solidFill>
+                  </a:tcPr>
+                </a:tc>
+                <a:tc>
+                  <a:txBody>
+                    <a:bodyPr wrap="square"/>
+                    <a:lstStyle/>
+                    <a:p>
+                      <a:r>
+                        <a:rPr sz="1400" b="0">
+                          <a:solidFill>
+                            <a:srgbClr val="1B2A41"/>
+                          </a:solidFill>
+                          <a:latin typeface="Calibri"/>
+                        </a:rPr>
+                        <a:t>0.58</a:t>
+                      </a:r>
+                    </a:p>
+                  </a:txBody>
+                  <a:tcPr marL="54864" marR="54864" marT="27432" marB="27432">
+                    <a:solidFill>
+                      <a:srgbClr val="EEF3F8"/>
+                    </a:solidFill>
+                  </a:tcPr>
+                </a:tc>
+                <a:tc>
+                  <a:txBody>
+                    <a:bodyPr wrap="square"/>
+                    <a:lstStyle/>
+                    <a:p>
+                      <a:r>
+                        <a:rPr sz="1400" b="0">
+                          <a:solidFill>
+                            <a:srgbClr val="1B2A41"/>
+                          </a:solidFill>
+                          <a:latin typeface="Calibri"/>
+                        </a:rPr>
+                        <a:t>0.48</a:t>
+                      </a:r>
+                    </a:p>
+                  </a:txBody>
+                  <a:tcPr marL="54864" marR="54864" marT="27432" marB="27432">
+                    <a:solidFill>
+                      <a:srgbClr val="EEF3F8"/>
+                    </a:solidFill>
+                  </a:tcPr>
+                </a:tc>
+              </a:tr>
+              <a:tr h="548640">
+                <a:tc>
+                  <a:txBody>
+                    <a:bodyPr wrap="square"/>
+                    <a:lstStyle/>
+                    <a:p>
+                      <a:r>
+                        <a:rPr sz="1400" b="1">
+                          <a:solidFill>
+                            <a:srgbClr val="1B2A41"/>
+                          </a:solidFill>
+                          <a:latin typeface="Calibri"/>
+                        </a:rPr>
+                        <a:t>Logistic Regression — smote</a:t>
+                      </a:r>
+                    </a:p>
+                  </a:txBody>
+                  <a:tcPr marL="54864" marR="54864" marT="27432" marB="27432">
+                    <a:solidFill>
+                      <a:srgbClr val="FFFFFF"/>
+                    </a:solidFill>
+                  </a:tcPr>
+                </a:tc>
+                <a:tc>
+                  <a:txBody>
+                    <a:bodyPr wrap="square"/>
+                    <a:lstStyle/>
+                    <a:p>
+                      <a:r>
+                        <a:rPr sz="1400" b="0">
+                          <a:solidFill>
+                            <a:srgbClr val="1B2A41"/>
+                          </a:solidFill>
+                          <a:latin typeface="Calibri"/>
+                        </a:rPr>
+                        <a:t>0.85</a:t>
+                      </a:r>
+                    </a:p>
+                  </a:txBody>
+                  <a:tcPr marL="54864" marR="54864" marT="27432" marB="27432">
+                    <a:solidFill>
+                      <a:srgbClr val="FFFFFF"/>
+                    </a:solidFill>
+                  </a:tcPr>
+                </a:tc>
+                <a:tc>
+                  <a:txBody>
+                    <a:bodyPr wrap="square"/>
+                    <a:lstStyle/>
+                    <a:p>
+                      <a:r>
+                        <a:rPr sz="1400" b="0">
+                          <a:solidFill>
+                            <a:srgbClr val="1B2A41"/>
+                          </a:solidFill>
+                          <a:latin typeface="Calibri"/>
+                        </a:rPr>
+                        <a:t>0.80</a:t>
+                      </a:r>
+                    </a:p>
+                  </a:txBody>
+                  <a:tcPr marL="54864" marR="54864" marT="27432" marB="27432">
+                    <a:solidFill>
+                      <a:srgbClr val="FFFFFF"/>
+                    </a:solidFill>
+                  </a:tcPr>
+                </a:tc>
+                <a:tc>
+                  <a:txBody>
+                    <a:bodyPr wrap="square"/>
+                    <a:lstStyle/>
+                    <a:p>
+                      <a:r>
+                        <a:rPr sz="1400" b="0">
+                          <a:solidFill>
+                            <a:srgbClr val="1B2A41"/>
+                          </a:solidFill>
+                          <a:latin typeface="Calibri"/>
+                        </a:rPr>
+                        <a:t>0.35</a:t>
+                      </a:r>
+                    </a:p>
+                  </a:txBody>
+                  <a:tcPr marL="54864" marR="54864" marT="27432" marB="27432">
+                    <a:solidFill>
+                      <a:srgbClr val="FFFFFF"/>
+                    </a:solidFill>
+                  </a:tcPr>
+                </a:tc>
+                <a:tc>
+                  <a:txBody>
+                    <a:bodyPr wrap="square"/>
+                    <a:lstStyle/>
+                    <a:p>
+                      <a:r>
+                        <a:rPr sz="1400" b="0">
+                          <a:solidFill>
+                            <a:srgbClr val="1B2A41"/>
+                          </a:solidFill>
+                          <a:latin typeface="Calibri"/>
+                        </a:rPr>
+                        <a:t>0.49</a:t>
+                      </a:r>
+                    </a:p>
+                  </a:txBody>
+                  <a:tcPr marL="54864" marR="54864" marT="27432" marB="27432">
+                    <a:solidFill>
+                      <a:srgbClr val="FFFFFF"/>
+                    </a:solidFill>
+                  </a:tcPr>
+                </a:tc>
+                <a:tc>
+                  <a:txBody>
+                    <a:bodyPr wrap="square"/>
+                    <a:lstStyle/>
+                    <a:p>
+                      <a:r>
+                        <a:rPr sz="1400" b="0">
+                          <a:solidFill>
+                            <a:srgbClr val="1B2A41"/>
+                          </a:solidFill>
+                          <a:latin typeface="Calibri"/>
+                        </a:rPr>
+                        <a:t>0.83</a:t>
+                      </a:r>
+                    </a:p>
+                  </a:txBody>
+                  <a:tcPr marL="54864" marR="54864" marT="27432" marB="27432">
+                    <a:solidFill>
+                      <a:srgbClr val="FFFFFF"/>
+                    </a:solidFill>
+                  </a:tcPr>
+                </a:tc>
+                <a:tc>
+                  <a:txBody>
+                    <a:bodyPr wrap="square"/>
+                    <a:lstStyle/>
+                    <a:p>
+                      <a:r>
+                        <a:rPr sz="1400" b="0">
+                          <a:solidFill>
+                            <a:srgbClr val="1B2A41"/>
+                          </a:solidFill>
+                          <a:latin typeface="Calibri"/>
+                        </a:rPr>
+                        <a:t>0.46</a:t>
+                      </a:r>
+                    </a:p>
+                  </a:txBody>
+                  <a:tcPr marL="54864" marR="54864" marT="27432" marB="27432">
+                    <a:solidFill>
+                      <a:srgbClr val="FFFFFF"/>
+                    </a:solidFill>
+                  </a:tcPr>
+                </a:tc>
+              </a:tr>
+              <a:tr h="548640">
+                <a:tc>
+                  <a:txBody>
+                    <a:bodyPr wrap="square"/>
+                    <a:lstStyle/>
+                    <a:p>
+                      <a:r>
+                        <a:rPr sz="1400" b="1">
+                          <a:solidFill>
+                            <a:srgbClr val="1B2A41"/>
+                          </a:solidFill>
+                          <a:latin typeface="Calibri"/>
+                        </a:rPr>
+                        <a:t>Random Forest — baseline</a:t>
+                      </a:r>
+                    </a:p>
+                  </a:txBody>
+                  <a:tcPr marL="54864" marR="54864" marT="27432" marB="27432">
+                    <a:solidFill>
+                      <a:srgbClr val="EEF3F8"/>
+                    </a:solidFill>
+                  </a:tcPr>
+                </a:tc>
+                <a:tc>
+                  <a:txBody>
+                    <a:bodyPr wrap="square"/>
+                    <a:lstStyle/>
+                    <a:p>
+                      <a:r>
+                        <a:rPr sz="1400" b="0">
+                          <a:solidFill>
+                            <a:srgbClr val="1B2A41"/>
+                          </a:solidFill>
+                          <a:latin typeface="Calibri"/>
+                        </a:rPr>
+                        <a:t>0.92</a:t>
+                      </a:r>
+                    </a:p>
+                  </a:txBody>
+                  <a:tcPr marL="54864" marR="54864" marT="27432" marB="27432">
+                    <a:solidFill>
+                      <a:srgbClr val="EEF3F8"/>
+                    </a:solidFill>
+                  </a:tcPr>
+                </a:tc>
+                <a:tc>
+                  <a:txBody>
+                    <a:bodyPr wrap="square"/>
+                    <a:lstStyle/>
+                    <a:p>
+                      <a:r>
+                        <a:rPr sz="1400" b="0">
+                          <a:solidFill>
+                            <a:srgbClr val="1B2A41"/>
+                          </a:solidFill>
+                          <a:latin typeface="Calibri"/>
+                        </a:rPr>
+                        <a:t>0.25</a:t>
+                      </a:r>
+                    </a:p>
+                  </a:txBody>
+                  <a:tcPr marL="54864" marR="54864" marT="27432" marB="27432">
+                    <a:solidFill>
+                      <a:srgbClr val="EEF3F8"/>
+                    </a:solidFill>
+                  </a:tcPr>
+                </a:tc>
+                <a:tc>
+                  <a:txBody>
+                    <a:bodyPr wrap="square"/>
+                    <a:lstStyle/>
+                    <a:p>
+                      <a:r>
+                        <a:rPr sz="1400" b="0">
+                          <a:solidFill>
+                            <a:srgbClr val="1B2A41"/>
+                          </a:solidFill>
+                          <a:latin typeface="Calibri"/>
+                        </a:rPr>
+                        <a:t>0.67</a:t>
+                      </a:r>
+                    </a:p>
+                  </a:txBody>
+                  <a:tcPr marL="54864" marR="54864" marT="27432" marB="27432">
+                    <a:solidFill>
+                      <a:srgbClr val="EEF3F8"/>
+                    </a:solidFill>
+                  </a:tcPr>
+                </a:tc>
+                <a:tc>
+                  <a:txBody>
+                    <a:bodyPr wrap="square"/>
+                    <a:lstStyle/>
+                    <a:p>
+                      <a:r>
+                        <a:rPr sz="1400" b="0">
+                          <a:solidFill>
+                            <a:srgbClr val="1B2A41"/>
+                          </a:solidFill>
+                          <a:latin typeface="Calibri"/>
+                        </a:rPr>
+                        <a:t>0.36</a:t>
+                      </a:r>
+                    </a:p>
+                  </a:txBody>
+                  <a:tcPr marL="54864" marR="54864" marT="27432" marB="27432">
+                    <a:solidFill>
+                      <a:srgbClr val="EEF3F8"/>
+                    </a:solidFill>
+                  </a:tcPr>
+                </a:tc>
+                <a:tc>
+                  <a:txBody>
+                    <a:bodyPr wrap="square"/>
+                    <a:lstStyle/>
+                    <a:p>
+                      <a:r>
+                        <a:rPr sz="1400" b="0">
+                          <a:solidFill>
+                            <a:srgbClr val="1B2A41"/>
+                          </a:solidFill>
+                          <a:latin typeface="Calibri"/>
+                        </a:rPr>
+                        <a:t>0.62</a:t>
+                      </a:r>
+                    </a:p>
+                  </a:txBody>
+                  <a:tcPr marL="54864" marR="54864" marT="27432" marB="27432">
+                    <a:solidFill>
+                      <a:srgbClr val="EEF3F8"/>
+                    </a:solidFill>
+                  </a:tcPr>
+                </a:tc>
+                <a:tc>
+                  <a:txBody>
+                    <a:bodyPr wrap="square"/>
+                    <a:lstStyle/>
+                    <a:p>
+                      <a:r>
+                        <a:rPr sz="1400" b="0">
+                          <a:solidFill>
+                            <a:srgbClr val="1B2A41"/>
+                          </a:solidFill>
+                          <a:latin typeface="Calibri"/>
+                        </a:rPr>
+                        <a:t>0.47</a:t>
+                      </a:r>
+                    </a:p>
+                  </a:txBody>
+                  <a:tcPr marL="54864" marR="54864" marT="27432" marB="27432">
+                    <a:solidFill>
+                      <a:srgbClr val="EEF3F8"/>
+                    </a:solidFill>
+                  </a:tcPr>
+                </a:tc>
+              </a:tr>
+              <a:tr h="548640">
+                <a:tc>
+                  <a:txBody>
+                    <a:bodyPr wrap="square"/>
+                    <a:lstStyle/>
+                    <a:p>
+                      <a:r>
+                        <a:rPr sz="1400" b="1">
+                          <a:solidFill>
+                            <a:srgbClr val="1B2A41"/>
+                          </a:solidFill>
+                          <a:latin typeface="Calibri"/>
+                        </a:rPr>
+                        <a:t>Random Forest — class weighting</a:t>
+                      </a:r>
+                    </a:p>
+                  </a:txBody>
+                  <a:tcPr marL="54864" marR="54864" marT="27432" marB="27432">
+                    <a:solidFill>
+                      <a:srgbClr val="FFFFFF"/>
+                    </a:solidFill>
+                  </a:tcPr>
+                </a:tc>
+                <a:tc>
+                  <a:txBody>
+                    <a:bodyPr wrap="square"/>
+                    <a:lstStyle/>
+                    <a:p>
+                      <a:r>
+                        <a:rPr sz="1400" b="0">
+                          <a:solidFill>
+                            <a:srgbClr val="1B2A41"/>
+                          </a:solidFill>
+                          <a:latin typeface="Calibri"/>
+                        </a:rPr>
+                        <a:t>0.90</a:t>
+                      </a:r>
+                    </a:p>
+                  </a:txBody>
+                  <a:tcPr marL="54864" marR="54864" marT="27432" marB="27432">
+                    <a:solidFill>
+                      <a:srgbClr val="FFFFFF"/>
+                    </a:solidFill>
+                  </a:tcPr>
+                </a:tc>
+                <a:tc>
+                  <a:txBody>
+                    <a:bodyPr wrap="square"/>
+                    <a:lstStyle/>
+                    <a:p>
+                      <a:r>
+                        <a:rPr sz="1400" b="0">
+                          <a:solidFill>
+                            <a:srgbClr val="1B2A41"/>
+                          </a:solidFill>
+                          <a:latin typeface="Calibri"/>
+                        </a:rPr>
+                        <a:t>0.55</a:t>
+                      </a:r>
+                    </a:p>
+                  </a:txBody>
+                  <a:tcPr marL="54864" marR="54864" marT="27432" marB="27432">
+                    <a:solidFill>
+                      <a:srgbClr val="FFFFFF"/>
+                    </a:solidFill>
+                  </a:tcPr>
+                </a:tc>
+                <a:tc>
+                  <a:txBody>
+                    <a:bodyPr wrap="square"/>
+                    <a:lstStyle/>
+                    <a:p>
+                      <a:r>
+                        <a:rPr sz="1400" b="0">
+                          <a:solidFill>
+                            <a:srgbClr val="1B2A41"/>
+                          </a:solidFill>
+                          <a:latin typeface="Calibri"/>
+                        </a:rPr>
+                        <a:t>0.43</a:t>
+                      </a:r>
+                    </a:p>
+                  </a:txBody>
+                  <a:tcPr marL="54864" marR="54864" marT="27432" marB="27432">
+                    <a:solidFill>
+                      <a:srgbClr val="FFFFFF"/>
+                    </a:solidFill>
+                  </a:tcPr>
+                </a:tc>
+                <a:tc>
+                  <a:txBody>
+                    <a:bodyPr wrap="square"/>
+                    <a:lstStyle/>
+                    <a:p>
+                      <a:r>
+                        <a:rPr sz="1400" b="0">
+                          <a:solidFill>
+                            <a:srgbClr val="1B2A41"/>
+                          </a:solidFill>
+                          <a:latin typeface="Calibri"/>
+                        </a:rPr>
+                        <a:t>0.48</a:t>
+                      </a:r>
+                    </a:p>
+                  </a:txBody>
+                  <a:tcPr marL="54864" marR="54864" marT="27432" marB="27432">
+                    <a:solidFill>
+                      <a:srgbClr val="FFFFFF"/>
+                    </a:solidFill>
+                  </a:tcPr>
+                </a:tc>
+                <a:tc>
+                  <a:txBody>
+                    <a:bodyPr wrap="square"/>
+                    <a:lstStyle/>
+                    <a:p>
+                      <a:r>
+                        <a:rPr sz="1400" b="0">
+                          <a:solidFill>
+                            <a:srgbClr val="1B2A41"/>
+                          </a:solidFill>
+                          <a:latin typeface="Calibri"/>
+                        </a:rPr>
+                        <a:t>0.74</a:t>
+                      </a:r>
+                    </a:p>
+                  </a:txBody>
+                  <a:tcPr marL="54864" marR="54864" marT="27432" marB="27432">
+                    <a:solidFill>
+                      <a:srgbClr val="FFFFFF"/>
+                    </a:solidFill>
+                  </a:tcPr>
+                </a:tc>
+                <a:tc>
+                  <a:txBody>
+                    <a:bodyPr wrap="square"/>
+                    <a:lstStyle/>
+                    <a:p>
+                      <a:r>
+                        <a:rPr sz="1400" b="0">
+                          <a:solidFill>
+                            <a:srgbClr val="1B2A41"/>
+                          </a:solidFill>
+                          <a:latin typeface="Calibri"/>
+                        </a:rPr>
+                        <a:t>0.45</a:t>
+                      </a:r>
+                    </a:p>
+                  </a:txBody>
+                  <a:tcPr marL="54864" marR="54864" marT="27432" marB="27432">
+                    <a:solidFill>
+                      <a:srgbClr val="FFFFFF"/>
+                    </a:solidFill>
+                  </a:tcPr>
+                </a:tc>
+              </a:tr>
+            </a:tbl>
+          </a:graphicData>
+        </a:graphic>
+      </p:graphicFrame>
+      <p:pic>
+        <p:nvPicPr>
+          <p:cNvPr id="8" name="Picture 7" descr="fig4_before_after_metrics.png"/>
+          <p:cNvPicPr>
+            <a:picLocks noChangeAspect="1"/>
+          </p:cNvPicPr>
+          <p:nvPr/>
+        </p:nvPicPr>
+        <p:blipFill>
+          <a:blip r:embed="rId3"/>
+          <a:stretch>
+            <a:fillRect/>
+          </a:stretch>
+        </p:blipFill>
+        <p:spPr>
+          <a:xfrm>
+            <a:off x="822960" y="4160520"/>
+            <a:ext cx="6678482" cy="2240280"/>
+          </a:xfrm>
+          <a:prstGeom prst="rect">
+            <a:avLst/>
           </a:prstGeom>
-          <a:solidFill>
-            <a:srgbClr val="FDEDEC"/>
-          </a:solidFill>
-          <a:ln>
-            <a:solidFill>
-              <a:srgbClr val="2E86C1"/>
-            </a:solidFill>
-          </a:ln>
-        </p:spPr>
-        <p:style>
-          <a:lnRef idx="1">
-            <a:schemeClr val="accent1"/>
-          </a:lnRef>
-          <a:fillRef idx="3">
-            <a:schemeClr val="accent1"/>
-          </a:fillRef>
-          <a:effectRef idx="2">
-            <a:schemeClr val="accent1"/>
-          </a:effectRef>
-          <a:fontRef idx="minor">
-            <a:schemeClr val="lt1"/>
-          </a:fontRef>
-        </p:style>
-        <p:txBody>
-          <a:bodyPr rtlCol="0" anchor="ctr" wrap="square" lIns="137160" rIns="137160"/>
-          <a:lstStyle/>
-          <a:p>
-            <a:pPr algn="l"/>
-            <a:r>
-              <a:rPr sz="1600">
-                <a:solidFill>
-                  <a:srgbClr val="C0392B"/>
-                </a:solidFill>
-                <a:latin typeface="Calibri"/>
-              </a:rPr>
-              <a:t>[Results table appears here after the notebook is run — Results/q2_summary_before_after.csv]</a:t>
-            </a:r>
-          </a:p>
-        </p:txBody>
-      </p:sp>
-      <p:sp>
-        <p:nvSpPr>
-          <p:cNvPr id="8" name="Rounded Rectangle 7"/>
-          <p:cNvSpPr/>
-          <p:nvPr/>
-        </p:nvSpPr>
-        <p:spPr>
-          <a:xfrm>
-            <a:off x="822960" y="4160520"/>
-            <a:ext cx="4572000" cy="2240280"/>
-          </a:xfrm>
-          <a:prstGeom prst="roundRect">
-            <a:avLst>
-              <a:gd name="adj" fmla="val 8000"/>
-            </a:avLst>
-          </a:prstGeom>
-          <a:solidFill>
-            <a:srgbClr val="FDEDEC"/>
-          </a:solidFill>
-          <a:ln>
-            <a:solidFill>
-              <a:srgbClr val="2E86C1"/>
-            </a:solidFill>
-          </a:ln>
-        </p:spPr>
-        <p:style>
-          <a:lnRef idx="1">
-            <a:schemeClr val="accent1"/>
-          </a:lnRef>
-          <a:fillRef idx="3">
-            <a:schemeClr val="accent1"/>
-          </a:fillRef>
-          <a:effectRef idx="2">
-            <a:schemeClr val="accent1"/>
-          </a:effectRef>
-          <a:fontRef idx="minor">
-            <a:schemeClr val="lt1"/>
-          </a:fontRef>
-        </p:style>
-        <p:txBody>
-          <a:bodyPr rtlCol="0" anchor="ctr" wrap="square" lIns="137160" rIns="137160"/>
-          <a:lstStyle/>
-          <a:p>
-            <a:pPr algn="l"/>
-            <a:r>
-              <a:rPr sz="1600">
-                <a:solidFill>
-                  <a:srgbClr val="C0392B"/>
-                </a:solidFill>
-                <a:latin typeface="Calibri"/>
-              </a:rPr>
-              <a:t>[Figure missing: fig4_before_after_metrics.png — run the notebook]</a:t>
-            </a:r>
-          </a:p>
-        </p:txBody>
-      </p:sp>
+        </p:spPr>
+      </p:pic>
     </p:spTree>
   </p:cSld>
   <p:clrMapOvr>
@@ -7331,118 +8088,54 @@
           </a:p>
         </p:txBody>
       </p:sp>
-      <p:sp>
-        <p:nvSpPr>
-          <p:cNvPr id="7" name="Rounded Rectangle 6"/>
-          <p:cNvSpPr/>
+      <p:pic>
+        <p:nvPicPr>
+          <p:cNvPr id="7" name="Picture 6" descr="fig5_confusion_matrices.png"/>
+          <p:cNvPicPr>
+            <a:picLocks noChangeAspect="1"/>
+          </p:cNvPicPr>
           <p:nvPr/>
-        </p:nvSpPr>
+        </p:nvPicPr>
+        <p:blipFill>
+          <a:blip r:embed="rId3"/>
+          <a:stretch>
+            <a:fillRect/>
+          </a:stretch>
+        </p:blipFill>
         <p:spPr>
           <a:xfrm>
             <a:off x="365760" y="1143000"/>
-            <a:ext cx="4572000" cy="5212080"/>
-          </a:xfrm>
-          <a:prstGeom prst="roundRect">
-            <a:avLst>
-              <a:gd name="adj" fmla="val 8000"/>
-            </a:avLst>
+            <a:ext cx="5463987" cy="5212080"/>
+          </a:xfrm>
+          <a:prstGeom prst="rect">
+            <a:avLst/>
           </a:prstGeom>
-          <a:solidFill>
-            <a:srgbClr val="FDEDEC"/>
-          </a:solidFill>
-          <a:ln>
-            <a:solidFill>
-              <a:srgbClr val="2E86C1"/>
-            </a:solidFill>
-          </a:ln>
-        </p:spPr>
-        <p:style>
-          <a:lnRef idx="1">
-            <a:schemeClr val="accent1"/>
-          </a:lnRef>
-          <a:fillRef idx="3">
-            <a:schemeClr val="accent1"/>
-          </a:fillRef>
-          <a:effectRef idx="2">
-            <a:schemeClr val="accent1"/>
-          </a:effectRef>
-          <a:fontRef idx="minor">
-            <a:schemeClr val="lt1"/>
-          </a:fontRef>
-        </p:style>
-        <p:txBody>
-          <a:bodyPr rtlCol="0" anchor="ctr" wrap="square" lIns="137160" rIns="137160"/>
-          <a:lstStyle/>
-          <a:p>
-            <a:pPr algn="l"/>
-            <a:r>
-              <a:rPr sz="1600">
-                <a:solidFill>
-                  <a:srgbClr val="C0392B"/>
-                </a:solidFill>
-                <a:latin typeface="Calibri"/>
-              </a:rPr>
-              <a:t>[Figure missing: fig5_confusion_matrices.png — run the notebook]</a:t>
-            </a:r>
-          </a:p>
-        </p:txBody>
-      </p:sp>
-      <p:sp>
-        <p:nvSpPr>
-          <p:cNvPr id="8" name="Rounded Rectangle 7"/>
-          <p:cNvSpPr/>
+        </p:spPr>
+      </p:pic>
+      <p:pic>
+        <p:nvPicPr>
+          <p:cNvPr id="8" name="Picture 7" descr="fig6_pr_curves.png"/>
+          <p:cNvPicPr>
+            <a:picLocks noChangeAspect="1"/>
+          </p:cNvPicPr>
           <p:nvPr/>
-        </p:nvSpPr>
+        </p:nvPicPr>
+        <p:blipFill>
+          <a:blip r:embed="rId4"/>
+          <a:stretch>
+            <a:fillRect/>
+          </a:stretch>
+        </p:blipFill>
         <p:spPr>
           <a:xfrm>
             <a:off x="5852160" y="2011680"/>
-            <a:ext cx="6126480" cy="2743200"/>
-          </a:xfrm>
-          <a:prstGeom prst="roundRect">
-            <a:avLst>
-              <a:gd name="adj" fmla="val 8000"/>
-            </a:avLst>
+            <a:ext cx="6126480" cy="2570272"/>
+          </a:xfrm>
+          <a:prstGeom prst="rect">
+            <a:avLst/>
           </a:prstGeom>
-          <a:solidFill>
-            <a:srgbClr val="FDEDEC"/>
-          </a:solidFill>
-          <a:ln>
-            <a:solidFill>
-              <a:srgbClr val="2E86C1"/>
-            </a:solidFill>
-          </a:ln>
-        </p:spPr>
-        <p:style>
-          <a:lnRef idx="1">
-            <a:schemeClr val="accent1"/>
-          </a:lnRef>
-          <a:fillRef idx="3">
-            <a:schemeClr val="accent1"/>
-          </a:fillRef>
-          <a:effectRef idx="2">
-            <a:schemeClr val="accent1"/>
-          </a:effectRef>
-          <a:fontRef idx="minor">
-            <a:schemeClr val="lt1"/>
-          </a:fontRef>
-        </p:style>
-        <p:txBody>
-          <a:bodyPr rtlCol="0" anchor="ctr" wrap="square" lIns="137160" rIns="137160"/>
-          <a:lstStyle/>
-          <a:p>
-            <a:pPr algn="l"/>
-            <a:r>
-              <a:rPr sz="1600">
-                <a:solidFill>
-                  <a:srgbClr val="C0392B"/>
-                </a:solidFill>
-                <a:latin typeface="Calibri"/>
-              </a:rPr>
-              <a:t>[Figure missing: fig6_pr_curves.png — run the notebook]</a:t>
-            </a:r>
-          </a:p>
-        </p:txBody>
-      </p:sp>
+        </p:spPr>
+      </p:pic>
     </p:spTree>
   </p:cSld>
   <p:clrMapOvr>
@@ -7644,16 +8337,827 @@
           </a:p>
         </p:txBody>
       </p:sp>
-      <p:sp>
-        <p:nvSpPr>
-          <p:cNvPr id="7" name="TextBox 6"/>
+      <p:graphicFrame>
+        <p:nvGraphicFramePr>
+          <p:cNvPr id="7" name="Table 6"/>
+          <p:cNvGraphicFramePr>
+            <a:graphicFrameLocks noGrp="1"/>
+          </p:cNvGraphicFramePr>
+          <p:nvPr/>
+        </p:nvGraphicFramePr>
+        <p:xfrm>
+          <a:off x="365760" y="1188720"/>
+          <a:ext cx="11429995" cy="2286000"/>
+        </p:xfrm>
+        <a:graphic>
+          <a:graphicData uri="http://schemas.openxmlformats.org/drawingml/2006/table">
+            <a:tbl>
+              <a:tblPr firstRow="1" bandRow="1">
+                <a:tableStyleId>{5C22544A-7EE6-4342-B048-85BDC9FD1C3A}</a:tableStyleId>
+              </a:tblPr>
+              <a:tblGrid>
+                <a:gridCol w="3372786"/>
+                <a:gridCol w="1405327"/>
+                <a:gridCol w="1405327"/>
+                <a:gridCol w="1217950"/>
+                <a:gridCol w="1499016"/>
+                <a:gridCol w="1311639"/>
+                <a:gridCol w="1217950"/>
+              </a:tblGrid>
+              <a:tr h="457200">
+                <a:tc>
+                  <a:txBody>
+                    <a:bodyPr wrap="square"/>
+                    <a:lstStyle/>
+                    <a:p>
+                      <a:r>
+                        <a:rPr sz="1400" b="1">
+                          <a:solidFill>
+                            <a:srgbClr val="FFFFFF"/>
+                          </a:solidFill>
+                          <a:latin typeface="Calibri"/>
+                        </a:rPr>
+                        <a:t>Test set (73 old of 835)</a:t>
+                      </a:r>
+                    </a:p>
+                  </a:txBody>
+                  <a:tcPr marL="54864" marR="54864" marT="27432" marB="27432">
+                    <a:solidFill>
+                      <a:srgbClr val="2E86C1"/>
+                    </a:solidFill>
+                  </a:tcPr>
+                </a:tc>
+                <a:tc>
+                  <a:txBody>
+                    <a:bodyPr wrap="square"/>
+                    <a:lstStyle/>
+                    <a:p>
+                      <a:r>
+                        <a:rPr sz="1400" b="1">
+                          <a:solidFill>
+                            <a:srgbClr val="FFFFFF"/>
+                          </a:solidFill>
+                          <a:latin typeface="Calibri"/>
+                        </a:rPr>
+                        <a:t>Old found</a:t>
+                      </a:r>
+                    </a:p>
+                  </a:txBody>
+                  <a:tcPr marL="54864" marR="54864" marT="27432" marB="27432">
+                    <a:solidFill>
+                      <a:srgbClr val="2E86C1"/>
+                    </a:solidFill>
+                  </a:tcPr>
+                </a:tc>
+                <a:tc>
+                  <a:txBody>
+                    <a:bodyPr wrap="square"/>
+                    <a:lstStyle/>
+                    <a:p>
+                      <a:r>
+                        <a:rPr sz="1400" b="1">
+                          <a:solidFill>
+                            <a:srgbClr val="FFFFFF"/>
+                          </a:solidFill>
+                          <a:latin typeface="Calibri"/>
+                        </a:rPr>
+                        <a:t>False alarms</a:t>
+                      </a:r>
+                    </a:p>
+                  </a:txBody>
+                  <a:tcPr marL="54864" marR="54864" marT="27432" marB="27432">
+                    <a:solidFill>
+                      <a:srgbClr val="2E86C1"/>
+                    </a:solidFill>
+                  </a:tcPr>
+                </a:tc>
+                <a:tc>
+                  <a:txBody>
+                    <a:bodyPr wrap="square"/>
+                    <a:lstStyle/>
+                    <a:p>
+                      <a:r>
+                        <a:rPr sz="1400" b="1">
+                          <a:solidFill>
+                            <a:srgbClr val="FFFFFF"/>
+                          </a:solidFill>
+                          <a:latin typeface="Calibri"/>
+                        </a:rPr>
+                        <a:t>F1 (old)</a:t>
+                      </a:r>
+                    </a:p>
+                  </a:txBody>
+                  <a:tcPr marL="54864" marR="54864" marT="27432" marB="27432">
+                    <a:solidFill>
+                      <a:srgbClr val="2E86C1"/>
+                    </a:solidFill>
+                  </a:tcPr>
+                </a:tc>
+                <a:tc>
+                  <a:txBody>
+                    <a:bodyPr wrap="square"/>
+                    <a:lstStyle/>
+                    <a:p>
+                      <a:r>
+                        <a:rPr sz="1400" b="1">
+                          <a:solidFill>
+                            <a:srgbClr val="FFFFFF"/>
+                          </a:solidFill>
+                          <a:latin typeface="Calibri"/>
+                        </a:rPr>
+                        <a:t>Balanced acc.</a:t>
+                      </a:r>
+                    </a:p>
+                  </a:txBody>
+                  <a:tcPr marL="54864" marR="54864" marT="27432" marB="27432">
+                    <a:solidFill>
+                      <a:srgbClr val="2E86C1"/>
+                    </a:solidFill>
+                  </a:tcPr>
+                </a:tc>
+                <a:tc>
+                  <a:txBody>
+                    <a:bodyPr wrap="square"/>
+                    <a:lstStyle/>
+                    <a:p>
+                      <a:r>
+                        <a:rPr sz="1400" b="1">
+                          <a:solidFill>
+                            <a:srgbClr val="FFFFFF"/>
+                          </a:solidFill>
+                          <a:latin typeface="Calibri"/>
+                        </a:rPr>
+                        <a:t>Accuracy</a:t>
+                      </a:r>
+                    </a:p>
+                  </a:txBody>
+                  <a:tcPr marL="54864" marR="54864" marT="27432" marB="27432">
+                    <a:solidFill>
+                      <a:srgbClr val="2E86C1"/>
+                    </a:solidFill>
+                  </a:tcPr>
+                </a:tc>
+                <a:tc>
+                  <a:txBody>
+                    <a:bodyPr wrap="square"/>
+                    <a:lstStyle/>
+                    <a:p>
+                      <a:r>
+                        <a:rPr sz="1400" b="1">
+                          <a:solidFill>
+                            <a:srgbClr val="FFFFFF"/>
+                          </a:solidFill>
+                          <a:latin typeface="Calibri"/>
+                        </a:rPr>
+                        <a:t>PR-AUC</a:t>
+                      </a:r>
+                    </a:p>
+                  </a:txBody>
+                  <a:tcPr marL="54864" marR="54864" marT="27432" marB="27432">
+                    <a:solidFill>
+                      <a:srgbClr val="2E86C1"/>
+                    </a:solidFill>
+                  </a:tcPr>
+                </a:tc>
+              </a:tr>
+              <a:tr h="457200">
+                <a:tc>
+                  <a:txBody>
+                    <a:bodyPr wrap="square"/>
+                    <a:lstStyle/>
+                    <a:p>
+                      <a:r>
+                        <a:rPr sz="1400" b="1">
+                          <a:solidFill>
+                            <a:srgbClr val="1B2A41"/>
+                          </a:solidFill>
+                          <a:latin typeface="Calibri"/>
+                        </a:rPr>
+                        <a:t>Logistic Regression — baseline</a:t>
+                      </a:r>
+                    </a:p>
+                  </a:txBody>
+                  <a:tcPr marL="54864" marR="54864" marT="27432" marB="27432">
+                    <a:solidFill>
+                      <a:srgbClr val="EEF3F8"/>
+                    </a:solidFill>
+                  </a:tcPr>
+                </a:tc>
+                <a:tc>
+                  <a:txBody>
+                    <a:bodyPr wrap="square"/>
+                    <a:lstStyle/>
+                    <a:p>
+                      <a:r>
+                        <a:rPr sz="1400" b="0">
+                          <a:solidFill>
+                            <a:srgbClr val="1B2A41"/>
+                          </a:solidFill>
+                          <a:latin typeface="Calibri"/>
+                        </a:rPr>
+                        <a:t>13 (18%)</a:t>
+                      </a:r>
+                    </a:p>
+                  </a:txBody>
+                  <a:tcPr marL="54864" marR="54864" marT="27432" marB="27432">
+                    <a:solidFill>
+                      <a:srgbClr val="EEF3F8"/>
+                    </a:solidFill>
+                  </a:tcPr>
+                </a:tc>
+                <a:tc>
+                  <a:txBody>
+                    <a:bodyPr wrap="square"/>
+                    <a:lstStyle/>
+                    <a:p>
+                      <a:r>
+                        <a:rPr sz="1400" b="0">
+                          <a:solidFill>
+                            <a:srgbClr val="1B2A41"/>
+                          </a:solidFill>
+                          <a:latin typeface="Calibri"/>
+                        </a:rPr>
+                        <a:t>12</a:t>
+                      </a:r>
+                    </a:p>
+                  </a:txBody>
+                  <a:tcPr marL="54864" marR="54864" marT="27432" marB="27432">
+                    <a:solidFill>
+                      <a:srgbClr val="EEF3F8"/>
+                    </a:solidFill>
+                  </a:tcPr>
+                </a:tc>
+                <a:tc>
+                  <a:txBody>
+                    <a:bodyPr wrap="square"/>
+                    <a:lstStyle/>
+                    <a:p>
+                      <a:r>
+                        <a:rPr sz="1400" b="0">
+                          <a:solidFill>
+                            <a:srgbClr val="1B2A41"/>
+                          </a:solidFill>
+                          <a:latin typeface="Calibri"/>
+                        </a:rPr>
+                        <a:t>0.27</a:t>
+                      </a:r>
+                    </a:p>
+                  </a:txBody>
+                  <a:tcPr marL="54864" marR="54864" marT="27432" marB="27432">
+                    <a:solidFill>
+                      <a:srgbClr val="EEF3F8"/>
+                    </a:solidFill>
+                  </a:tcPr>
+                </a:tc>
+                <a:tc>
+                  <a:txBody>
+                    <a:bodyPr wrap="square"/>
+                    <a:lstStyle/>
+                    <a:p>
+                      <a:r>
+                        <a:rPr sz="1400" b="0">
+                          <a:solidFill>
+                            <a:srgbClr val="1B2A41"/>
+                          </a:solidFill>
+                          <a:latin typeface="Calibri"/>
+                        </a:rPr>
+                        <a:t>0.58</a:t>
+                      </a:r>
+                    </a:p>
+                  </a:txBody>
+                  <a:tcPr marL="54864" marR="54864" marT="27432" marB="27432">
+                    <a:solidFill>
+                      <a:srgbClr val="EEF3F8"/>
+                    </a:solidFill>
+                  </a:tcPr>
+                </a:tc>
+                <a:tc>
+                  <a:txBody>
+                    <a:bodyPr wrap="square"/>
+                    <a:lstStyle/>
+                    <a:p>
+                      <a:r>
+                        <a:rPr sz="1400" b="0">
+                          <a:solidFill>
+                            <a:srgbClr val="1B2A41"/>
+                          </a:solidFill>
+                          <a:latin typeface="Calibri"/>
+                        </a:rPr>
+                        <a:t>0.91</a:t>
+                      </a:r>
+                    </a:p>
+                  </a:txBody>
+                  <a:tcPr marL="54864" marR="54864" marT="27432" marB="27432">
+                    <a:solidFill>
+                      <a:srgbClr val="EEF3F8"/>
+                    </a:solidFill>
+                  </a:tcPr>
+                </a:tc>
+                <a:tc>
+                  <a:txBody>
+                    <a:bodyPr wrap="square"/>
+                    <a:lstStyle/>
+                    <a:p>
+                      <a:r>
+                        <a:rPr sz="1400" b="0">
+                          <a:solidFill>
+                            <a:srgbClr val="1B2A41"/>
+                          </a:solidFill>
+                          <a:latin typeface="Calibri"/>
+                        </a:rPr>
+                        <a:t>0.48</a:t>
+                      </a:r>
+                    </a:p>
+                  </a:txBody>
+                  <a:tcPr marL="54864" marR="54864" marT="27432" marB="27432">
+                    <a:solidFill>
+                      <a:srgbClr val="EEF3F8"/>
+                    </a:solidFill>
+                  </a:tcPr>
+                </a:tc>
+              </a:tr>
+              <a:tr h="457200">
+                <a:tc>
+                  <a:txBody>
+                    <a:bodyPr wrap="square"/>
+                    <a:lstStyle/>
+                    <a:p>
+                      <a:r>
+                        <a:rPr sz="1400" b="1">
+                          <a:solidFill>
+                            <a:srgbClr val="1B2A41"/>
+                          </a:solidFill>
+                          <a:latin typeface="Calibri"/>
+                        </a:rPr>
+                        <a:t>Logistic Regression — SMOTE</a:t>
+                      </a:r>
+                    </a:p>
+                  </a:txBody>
+                  <a:tcPr marL="54864" marR="54864" marT="27432" marB="27432">
+                    <a:solidFill>
+                      <a:srgbClr val="FFFFFF"/>
+                    </a:solidFill>
+                  </a:tcPr>
+                </a:tc>
+                <a:tc>
+                  <a:txBody>
+                    <a:bodyPr wrap="square"/>
+                    <a:lstStyle/>
+                    <a:p>
+                      <a:r>
+                        <a:rPr sz="1400" b="0">
+                          <a:solidFill>
+                            <a:srgbClr val="1B2A41"/>
+                          </a:solidFill>
+                          <a:latin typeface="Calibri"/>
+                        </a:rPr>
+                        <a:t>58 (79%)</a:t>
+                      </a:r>
+                    </a:p>
+                  </a:txBody>
+                  <a:tcPr marL="54864" marR="54864" marT="27432" marB="27432">
+                    <a:solidFill>
+                      <a:srgbClr val="FFFFFF"/>
+                    </a:solidFill>
+                  </a:tcPr>
+                </a:tc>
+                <a:tc>
+                  <a:txBody>
+                    <a:bodyPr wrap="square"/>
+                    <a:lstStyle/>
+                    <a:p>
+                      <a:r>
+                        <a:rPr sz="1400" b="0">
+                          <a:solidFill>
+                            <a:srgbClr val="1B2A41"/>
+                          </a:solidFill>
+                          <a:latin typeface="Calibri"/>
+                        </a:rPr>
+                        <a:t>107</a:t>
+                      </a:r>
+                    </a:p>
+                  </a:txBody>
+                  <a:tcPr marL="54864" marR="54864" marT="27432" marB="27432">
+                    <a:solidFill>
+                      <a:srgbClr val="FFFFFF"/>
+                    </a:solidFill>
+                  </a:tcPr>
+                </a:tc>
+                <a:tc>
+                  <a:txBody>
+                    <a:bodyPr wrap="square"/>
+                    <a:lstStyle/>
+                    <a:p>
+                      <a:r>
+                        <a:rPr sz="1400" b="0">
+                          <a:solidFill>
+                            <a:srgbClr val="1B2A41"/>
+                          </a:solidFill>
+                          <a:latin typeface="Calibri"/>
+                        </a:rPr>
+                        <a:t>0.49</a:t>
+                      </a:r>
+                    </a:p>
+                  </a:txBody>
+                  <a:tcPr marL="54864" marR="54864" marT="27432" marB="27432">
+                    <a:solidFill>
+                      <a:srgbClr val="FFFFFF"/>
+                    </a:solidFill>
+                  </a:tcPr>
+                </a:tc>
+                <a:tc>
+                  <a:txBody>
+                    <a:bodyPr wrap="square"/>
+                    <a:lstStyle/>
+                    <a:p>
+                      <a:r>
+                        <a:rPr sz="1400" b="0">
+                          <a:solidFill>
+                            <a:srgbClr val="1B2A41"/>
+                          </a:solidFill>
+                          <a:latin typeface="Calibri"/>
+                        </a:rPr>
+                        <a:t>0.83</a:t>
+                      </a:r>
+                    </a:p>
+                  </a:txBody>
+                  <a:tcPr marL="54864" marR="54864" marT="27432" marB="27432">
+                    <a:solidFill>
+                      <a:srgbClr val="FFFFFF"/>
+                    </a:solidFill>
+                  </a:tcPr>
+                </a:tc>
+                <a:tc>
+                  <a:txBody>
+                    <a:bodyPr wrap="square"/>
+                    <a:lstStyle/>
+                    <a:p>
+                      <a:r>
+                        <a:rPr sz="1400" b="0">
+                          <a:solidFill>
+                            <a:srgbClr val="1B2A41"/>
+                          </a:solidFill>
+                          <a:latin typeface="Calibri"/>
+                        </a:rPr>
+                        <a:t>0.85</a:t>
+                      </a:r>
+                    </a:p>
+                  </a:txBody>
+                  <a:tcPr marL="54864" marR="54864" marT="27432" marB="27432">
+                    <a:solidFill>
+                      <a:srgbClr val="FFFFFF"/>
+                    </a:solidFill>
+                  </a:tcPr>
+                </a:tc>
+                <a:tc>
+                  <a:txBody>
+                    <a:bodyPr wrap="square"/>
+                    <a:lstStyle/>
+                    <a:p>
+                      <a:r>
+                        <a:rPr sz="1400" b="0">
+                          <a:solidFill>
+                            <a:srgbClr val="1B2A41"/>
+                          </a:solidFill>
+                          <a:latin typeface="Calibri"/>
+                        </a:rPr>
+                        <a:t>0.46</a:t>
+                      </a:r>
+                    </a:p>
+                  </a:txBody>
+                  <a:tcPr marL="54864" marR="54864" marT="27432" marB="27432">
+                    <a:solidFill>
+                      <a:srgbClr val="FFFFFF"/>
+                    </a:solidFill>
+                  </a:tcPr>
+                </a:tc>
+              </a:tr>
+              <a:tr h="457200">
+                <a:tc>
+                  <a:txBody>
+                    <a:bodyPr wrap="square"/>
+                    <a:lstStyle/>
+                    <a:p>
+                      <a:r>
+                        <a:rPr sz="1400" b="1">
+                          <a:solidFill>
+                            <a:srgbClr val="1B2A41"/>
+                          </a:solidFill>
+                          <a:latin typeface="Calibri"/>
+                        </a:rPr>
+                        <a:t>Random Forest — baseline</a:t>
+                      </a:r>
+                    </a:p>
+                  </a:txBody>
+                  <a:tcPr marL="54864" marR="54864" marT="27432" marB="27432">
+                    <a:solidFill>
+                      <a:srgbClr val="EEF3F8"/>
+                    </a:solidFill>
+                  </a:tcPr>
+                </a:tc>
+                <a:tc>
+                  <a:txBody>
+                    <a:bodyPr wrap="square"/>
+                    <a:lstStyle/>
+                    <a:p>
+                      <a:r>
+                        <a:rPr sz="1400" b="0">
+                          <a:solidFill>
+                            <a:srgbClr val="1B2A41"/>
+                          </a:solidFill>
+                          <a:latin typeface="Calibri"/>
+                        </a:rPr>
+                        <a:t>18 (25%)</a:t>
+                      </a:r>
+                    </a:p>
+                  </a:txBody>
+                  <a:tcPr marL="54864" marR="54864" marT="27432" marB="27432">
+                    <a:solidFill>
+                      <a:srgbClr val="EEF3F8"/>
+                    </a:solidFill>
+                  </a:tcPr>
+                </a:tc>
+                <a:tc>
+                  <a:txBody>
+                    <a:bodyPr wrap="square"/>
+                    <a:lstStyle/>
+                    <a:p>
+                      <a:r>
+                        <a:rPr sz="1400" b="0">
+                          <a:solidFill>
+                            <a:srgbClr val="1B2A41"/>
+                          </a:solidFill>
+                          <a:latin typeface="Calibri"/>
+                        </a:rPr>
+                        <a:t>9</a:t>
+                      </a:r>
+                    </a:p>
+                  </a:txBody>
+                  <a:tcPr marL="54864" marR="54864" marT="27432" marB="27432">
+                    <a:solidFill>
+                      <a:srgbClr val="EEF3F8"/>
+                    </a:solidFill>
+                  </a:tcPr>
+                </a:tc>
+                <a:tc>
+                  <a:txBody>
+                    <a:bodyPr wrap="square"/>
+                    <a:lstStyle/>
+                    <a:p>
+                      <a:r>
+                        <a:rPr sz="1400" b="0">
+                          <a:solidFill>
+                            <a:srgbClr val="1B2A41"/>
+                          </a:solidFill>
+                          <a:latin typeface="Calibri"/>
+                        </a:rPr>
+                        <a:t>0.36</a:t>
+                      </a:r>
+                    </a:p>
+                  </a:txBody>
+                  <a:tcPr marL="54864" marR="54864" marT="27432" marB="27432">
+                    <a:solidFill>
+                      <a:srgbClr val="EEF3F8"/>
+                    </a:solidFill>
+                  </a:tcPr>
+                </a:tc>
+                <a:tc>
+                  <a:txBody>
+                    <a:bodyPr wrap="square"/>
+                    <a:lstStyle/>
+                    <a:p>
+                      <a:r>
+                        <a:rPr sz="1400" b="0">
+                          <a:solidFill>
+                            <a:srgbClr val="1B2A41"/>
+                          </a:solidFill>
+                          <a:latin typeface="Calibri"/>
+                        </a:rPr>
+                        <a:t>0.62</a:t>
+                      </a:r>
+                    </a:p>
+                  </a:txBody>
+                  <a:tcPr marL="54864" marR="54864" marT="27432" marB="27432">
+                    <a:solidFill>
+                      <a:srgbClr val="EEF3F8"/>
+                    </a:solidFill>
+                  </a:tcPr>
+                </a:tc>
+                <a:tc>
+                  <a:txBody>
+                    <a:bodyPr wrap="square"/>
+                    <a:lstStyle/>
+                    <a:p>
+                      <a:r>
+                        <a:rPr sz="1400" b="0">
+                          <a:solidFill>
+                            <a:srgbClr val="1B2A41"/>
+                          </a:solidFill>
+                          <a:latin typeface="Calibri"/>
+                        </a:rPr>
+                        <a:t>0.92</a:t>
+                      </a:r>
+                    </a:p>
+                  </a:txBody>
+                  <a:tcPr marL="54864" marR="54864" marT="27432" marB="27432">
+                    <a:solidFill>
+                      <a:srgbClr val="EEF3F8"/>
+                    </a:solidFill>
+                  </a:tcPr>
+                </a:tc>
+                <a:tc>
+                  <a:txBody>
+                    <a:bodyPr wrap="square"/>
+                    <a:lstStyle/>
+                    <a:p>
+                      <a:r>
+                        <a:rPr sz="1400" b="0">
+                          <a:solidFill>
+                            <a:srgbClr val="1B2A41"/>
+                          </a:solidFill>
+                          <a:latin typeface="Calibri"/>
+                        </a:rPr>
+                        <a:t>0.47</a:t>
+                      </a:r>
+                    </a:p>
+                  </a:txBody>
+                  <a:tcPr marL="54864" marR="54864" marT="27432" marB="27432">
+                    <a:solidFill>
+                      <a:srgbClr val="EEF3F8"/>
+                    </a:solidFill>
+                  </a:tcPr>
+                </a:tc>
+              </a:tr>
+              <a:tr h="457200">
+                <a:tc>
+                  <a:txBody>
+                    <a:bodyPr wrap="square"/>
+                    <a:lstStyle/>
+                    <a:p>
+                      <a:r>
+                        <a:rPr sz="1400" b="1">
+                          <a:solidFill>
+                            <a:srgbClr val="1B2A41"/>
+                          </a:solidFill>
+                          <a:latin typeface="Calibri"/>
+                        </a:rPr>
+                        <a:t>Random Forest — class weighting</a:t>
+                      </a:r>
+                    </a:p>
+                  </a:txBody>
+                  <a:tcPr marL="54864" marR="54864" marT="27432" marB="27432">
+                    <a:solidFill>
+                      <a:srgbClr val="FFFFFF"/>
+                    </a:solidFill>
+                  </a:tcPr>
+                </a:tc>
+                <a:tc>
+                  <a:txBody>
+                    <a:bodyPr wrap="square"/>
+                    <a:lstStyle/>
+                    <a:p>
+                      <a:r>
+                        <a:rPr sz="1400" b="0">
+                          <a:solidFill>
+                            <a:srgbClr val="1B2A41"/>
+                          </a:solidFill>
+                          <a:latin typeface="Calibri"/>
+                        </a:rPr>
+                        <a:t>40 (55%)</a:t>
+                      </a:r>
+                    </a:p>
+                  </a:txBody>
+                  <a:tcPr marL="54864" marR="54864" marT="27432" marB="27432">
+                    <a:solidFill>
+                      <a:srgbClr val="FFFFFF"/>
+                    </a:solidFill>
+                  </a:tcPr>
+                </a:tc>
+                <a:tc>
+                  <a:txBody>
+                    <a:bodyPr wrap="square"/>
+                    <a:lstStyle/>
+                    <a:p>
+                      <a:r>
+                        <a:rPr sz="1400" b="0">
+                          <a:solidFill>
+                            <a:srgbClr val="1B2A41"/>
+                          </a:solidFill>
+                          <a:latin typeface="Calibri"/>
+                        </a:rPr>
+                        <a:t>53</a:t>
+                      </a:r>
+                    </a:p>
+                  </a:txBody>
+                  <a:tcPr marL="54864" marR="54864" marT="27432" marB="27432">
+                    <a:solidFill>
+                      <a:srgbClr val="FFFFFF"/>
+                    </a:solidFill>
+                  </a:tcPr>
+                </a:tc>
+                <a:tc>
+                  <a:txBody>
+                    <a:bodyPr wrap="square"/>
+                    <a:lstStyle/>
+                    <a:p>
+                      <a:r>
+                        <a:rPr sz="1400" b="0">
+                          <a:solidFill>
+                            <a:srgbClr val="1B2A41"/>
+                          </a:solidFill>
+                          <a:latin typeface="Calibri"/>
+                        </a:rPr>
+                        <a:t>0.48</a:t>
+                      </a:r>
+                    </a:p>
+                  </a:txBody>
+                  <a:tcPr marL="54864" marR="54864" marT="27432" marB="27432">
+                    <a:solidFill>
+                      <a:srgbClr val="FFFFFF"/>
+                    </a:solidFill>
+                  </a:tcPr>
+                </a:tc>
+                <a:tc>
+                  <a:txBody>
+                    <a:bodyPr wrap="square"/>
+                    <a:lstStyle/>
+                    <a:p>
+                      <a:r>
+                        <a:rPr sz="1400" b="0">
+                          <a:solidFill>
+                            <a:srgbClr val="1B2A41"/>
+                          </a:solidFill>
+                          <a:latin typeface="Calibri"/>
+                        </a:rPr>
+                        <a:t>0.74</a:t>
+                      </a:r>
+                    </a:p>
+                  </a:txBody>
+                  <a:tcPr marL="54864" marR="54864" marT="27432" marB="27432">
+                    <a:solidFill>
+                      <a:srgbClr val="FFFFFF"/>
+                    </a:solidFill>
+                  </a:tcPr>
+                </a:tc>
+                <a:tc>
+                  <a:txBody>
+                    <a:bodyPr wrap="square"/>
+                    <a:lstStyle/>
+                    <a:p>
+                      <a:r>
+                        <a:rPr sz="1400" b="0">
+                          <a:solidFill>
+                            <a:srgbClr val="1B2A41"/>
+                          </a:solidFill>
+                          <a:latin typeface="Calibri"/>
+                        </a:rPr>
+                        <a:t>0.90</a:t>
+                      </a:r>
+                    </a:p>
+                  </a:txBody>
+                  <a:tcPr marL="54864" marR="54864" marT="27432" marB="27432">
+                    <a:solidFill>
+                      <a:srgbClr val="FFFFFF"/>
+                    </a:solidFill>
+                  </a:tcPr>
+                </a:tc>
+                <a:tc>
+                  <a:txBody>
+                    <a:bodyPr wrap="square"/>
+                    <a:lstStyle/>
+                    <a:p>
+                      <a:r>
+                        <a:rPr sz="1400" b="0">
+                          <a:solidFill>
+                            <a:srgbClr val="1B2A41"/>
+                          </a:solidFill>
+                          <a:latin typeface="Calibri"/>
+                        </a:rPr>
+                        <a:t>0.45</a:t>
+                      </a:r>
+                    </a:p>
+                  </a:txBody>
+                  <a:tcPr marL="54864" marR="54864" marT="27432" marB="27432">
+                    <a:solidFill>
+                      <a:srgbClr val="FFFFFF"/>
+                    </a:solidFill>
+                  </a:tcPr>
+                </a:tc>
+              </a:tr>
+            </a:tbl>
+          </a:graphicData>
+        </a:graphic>
+      </p:graphicFrame>
+      <p:sp>
+        <p:nvSpPr>
+          <p:cNvPr id="8" name="TextBox 7"/>
           <p:cNvSpPr txBox="1"/>
           <p:nvPr/>
         </p:nvSpPr>
         <p:spPr>
           <a:xfrm>
-            <a:off x="548640" y="1280160"/>
-            <a:ext cx="10972800" cy="4846320"/>
+            <a:off x="548640" y="3703320"/>
+            <a:ext cx="11155680" cy="2743200"/>
           </a:xfrm>
           <a:prstGeom prst="rect">
             <a:avLst/>
@@ -7668,133 +9172,126 @@
           <a:p>
             <a:pPr>
               <a:spcAft>
-                <a:spcPts val="600"/>
+                <a:spcPts val="400"/>
               </a:spcAft>
             </a:pPr>
             <a:r>
-              <a:rPr b="1" sz="1800">
+              <a:rPr b="1" sz="1500">
                 <a:solidFill>
                   <a:srgbClr val="1B2A41"/>
                 </a:solidFill>
                 <a:latin typeface="Calibri"/>
               </a:rPr>
-              <a:t>•  Accuracy is misleading:</a:t>
-            </a:r>
-            <a:r>
-              <a:rPr sz="1800">
+              <a:t>•  Before:</a:t>
+            </a:r>
+            <a:r>
+              <a:rPr sz="1500">
                 <a:solidFill>
                   <a:srgbClr val="1B2A41"/>
                 </a:solidFill>
                 <a:latin typeface="Calibri"/>
               </a:rPr>
-              <a:t> always guessing "not old" scores ~91% but finds no old abalone</a:t>
+              <a:t> 91-92% accuracy but only 18-25% of old abalone found — accuracy hides the problem</a:t>
             </a:r>
           </a:p>
           <a:p>
             <a:pPr>
               <a:spcAft>
-                <a:spcPts val="600"/>
+                <a:spcPts val="400"/>
               </a:spcAft>
             </a:pPr>
             <a:r>
-              <a:rPr sz="1800">
+              <a:rPr b="1" sz="1500">
                 <a:solidFill>
                   <a:srgbClr val="1B2A41"/>
                 </a:solidFill>
                 <a:latin typeface="Calibri"/>
               </a:rPr>
-              <a:t>•  *Handling the imbalance raised recall of the old class (see table) — the model now finds many more old abalone</a:t>
+              <a:t>•  After:</a:t>
+            </a:r>
+            <a:r>
+              <a:rPr sz="1500">
+                <a:solidFill>
+                  <a:srgbClr val="1B2A41"/>
+                </a:solidFill>
+                <a:latin typeface="Calibri"/>
+              </a:rPr>
+              <a:t> recall 55-79%, F1 up from ~0.3 to ~0.49, balanced accuracy up to 0.74-0.83 (CV agrees)</a:t>
             </a:r>
           </a:p>
           <a:p>
             <a:pPr>
               <a:spcAft>
-                <a:spcPts val="600"/>
+                <a:spcPts val="400"/>
               </a:spcAft>
             </a:pPr>
             <a:r>
-              <a:rPr b="1" sz="1800">
+              <a:rPr b="1" sz="1500">
                 <a:solidFill>
                   <a:srgbClr val="1B2A41"/>
                 </a:solidFill>
                 <a:latin typeface="Calibri"/>
               </a:rPr>
-              <a:t>•  The price:</a:t>
-            </a:r>
-            <a:r>
-              <a:rPr sz="1800">
+              <a:t>•  Price:</a:t>
+            </a:r>
+            <a:r>
+              <a:rPr sz="1500">
                 <a:solidFill>
                   <a:srgbClr val="1B2A41"/>
                 </a:solidFill>
                 <a:latin typeface="Calibri"/>
               </a:rPr>
-              <a:t> more false alarms (precision falls) and slightly lower accuracy — a normal trade-off</a:t>
+              <a:t> many more false alarms and slightly lower accuracy — the normal precision/recall trade-off</a:t>
             </a:r>
           </a:p>
           <a:p>
             <a:pPr>
               <a:spcAft>
-                <a:spcPts val="600"/>
+                <a:spcPts val="400"/>
               </a:spcAft>
             </a:pPr>
             <a:r>
-              <a:rPr sz="1800">
+              <a:rPr b="1" sz="1500">
                 <a:solidFill>
                   <a:srgbClr val="1B2A41"/>
                 </a:solidFill>
                 <a:latin typeface="Calibri"/>
               </a:rPr>
-              <a:t>•  *Which fix is best depends on the cost of each error (missing an old abalone vs a false alarm)</a:t>
+              <a:t>•  PR-AUC barely moves (~0.46):</a:t>
+            </a:r>
+            <a:r>
+              <a:rPr sz="1500">
+                <a:solidFill>
+                  <a:srgbClr val="1B2A41"/>
+                </a:solidFill>
+                <a:latin typeface="Calibri"/>
+              </a:rPr>
+              <a:t> the fixes shift the decision point; they don't make the model rank better</a:t>
             </a:r>
           </a:p>
           <a:p>
             <a:pPr>
               <a:spcAft>
-                <a:spcPts val="600"/>
+                <a:spcPts val="400"/>
               </a:spcAft>
             </a:pPr>
             <a:r>
-              <a:rPr b="1" sz="1800">
+              <a:rPr b="1" sz="1500">
                 <a:solidFill>
                   <a:srgbClr val="1B2A41"/>
                 </a:solidFill>
                 <a:latin typeface="Calibri"/>
               </a:rPr>
-              <a:t>•  Correct process matters:</a:t>
-            </a:r>
-            <a:r>
-              <a:rPr sz="1800">
+              <a:t>•  Choice:</a:t>
+            </a:r>
+            <a:r>
+              <a:rPr sz="1500">
                 <a:solidFill>
                   <a:srgbClr val="1B2A41"/>
                 </a:solidFill>
                 <a:latin typeface="Calibri"/>
               </a:rPr>
-              <a:t> split first, resample only training data, judge with CV, use recall/F1/PR-AUC</a:t>
-            </a:r>
-          </a:p>
-          <a:p>
-            <a:pPr>
-              <a:spcAft>
-                <a:spcPts val="600"/>
-              </a:spcAft>
-            </a:pPr>
-            <a:r>
-              <a:rPr b="1" sz="1800">
-                <a:solidFill>
-                  <a:srgbClr val="1B2A41"/>
-                </a:solidFill>
-                <a:latin typeface="Calibri"/>
-              </a:rPr>
-              <a:t>•  Limitation:</a:t>
-            </a:r>
-            <a:r>
-              <a:rPr sz="1800">
-                <a:solidFill>
-                  <a:srgbClr val="1B2A41"/>
-                </a:solidFill>
-                <a:latin typeface="Calibri"/>
-              </a:rPr>
-              <a:t> resampling cannot add real information — more real data on old abalone would help most</a:t>
+              <a:t> pick by the cost of each error; always split first and resample only training data</a:t>
             </a:r>
           </a:p>
         </p:txBody>
@@ -19660,118 +21157,54 @@
           </a:p>
         </p:txBody>
       </p:sp>
-      <p:sp>
-        <p:nvSpPr>
-          <p:cNvPr id="7" name="Rounded Rectangle 6"/>
-          <p:cNvSpPr/>
+      <p:pic>
+        <p:nvPicPr>
+          <p:cNvPr id="7" name="Picture 6" descr="fig1_rings_distribution.png"/>
+          <p:cNvPicPr>
+            <a:picLocks noChangeAspect="1"/>
+          </p:cNvPicPr>
           <p:nvPr/>
-        </p:nvSpPr>
+        </p:nvPicPr>
+        <p:blipFill>
+          <a:blip r:embed="rId3"/>
+          <a:stretch>
+            <a:fillRect/>
+          </a:stretch>
+        </p:blipFill>
         <p:spPr>
           <a:xfrm>
             <a:off x="365760" y="1188720"/>
-            <a:ext cx="6949440" cy="2743200"/>
-          </a:xfrm>
-          <a:prstGeom prst="roundRect">
-            <a:avLst>
-              <a:gd name="adj" fmla="val 8000"/>
-            </a:avLst>
+            <a:ext cx="6949440" cy="2576759"/>
+          </a:xfrm>
+          <a:prstGeom prst="rect">
+            <a:avLst/>
           </a:prstGeom>
-          <a:solidFill>
-            <a:srgbClr val="FDEDEC"/>
-          </a:solidFill>
-          <a:ln>
-            <a:solidFill>
-              <a:srgbClr val="2E86C1"/>
-            </a:solidFill>
-          </a:ln>
-        </p:spPr>
-        <p:style>
-          <a:lnRef idx="1">
-            <a:schemeClr val="accent1"/>
-          </a:lnRef>
-          <a:fillRef idx="3">
-            <a:schemeClr val="accent1"/>
-          </a:fillRef>
-          <a:effectRef idx="2">
-            <a:schemeClr val="accent1"/>
-          </a:effectRef>
-          <a:fontRef idx="minor">
-            <a:schemeClr val="lt1"/>
-          </a:fontRef>
-        </p:style>
-        <p:txBody>
-          <a:bodyPr rtlCol="0" anchor="ctr" wrap="square" lIns="137160" rIns="137160"/>
-          <a:lstStyle/>
-          <a:p>
-            <a:pPr algn="l"/>
-            <a:r>
-              <a:rPr sz="1600">
-                <a:solidFill>
-                  <a:srgbClr val="C0392B"/>
-                </a:solidFill>
-                <a:latin typeface="Calibri"/>
-              </a:rPr>
-              <a:t>[Figure missing: fig1_rings_distribution.png — run the notebook]</a:t>
-            </a:r>
-          </a:p>
-        </p:txBody>
-      </p:sp>
-      <p:sp>
-        <p:nvSpPr>
-          <p:cNvPr id="8" name="Rounded Rectangle 7"/>
-          <p:cNvSpPr/>
+        </p:spPr>
+      </p:pic>
+      <p:pic>
+        <p:nvPicPr>
+          <p:cNvPr id="8" name="Picture 7" descr="fig2_class_balance.png"/>
+          <p:cNvPicPr>
+            <a:picLocks noChangeAspect="1"/>
+          </p:cNvPicPr>
           <p:nvPr/>
-        </p:nvSpPr>
+        </p:nvPicPr>
+        <p:blipFill>
+          <a:blip r:embed="rId4"/>
+          <a:stretch>
+            <a:fillRect/>
+          </a:stretch>
+        </p:blipFill>
         <p:spPr>
           <a:xfrm>
             <a:off x="7589520" y="1188720"/>
-            <a:ext cx="4206240" cy="2743200"/>
-          </a:xfrm>
-          <a:prstGeom prst="roundRect">
-            <a:avLst>
-              <a:gd name="adj" fmla="val 8000"/>
-            </a:avLst>
+            <a:ext cx="4206240" cy="3180328"/>
+          </a:xfrm>
+          <a:prstGeom prst="rect">
+            <a:avLst/>
           </a:prstGeom>
-          <a:solidFill>
-            <a:srgbClr val="FDEDEC"/>
-          </a:solidFill>
-          <a:ln>
-            <a:solidFill>
-              <a:srgbClr val="2E86C1"/>
-            </a:solidFill>
-          </a:ln>
-        </p:spPr>
-        <p:style>
-          <a:lnRef idx="1">
-            <a:schemeClr val="accent1"/>
-          </a:lnRef>
-          <a:fillRef idx="3">
-            <a:schemeClr val="accent1"/>
-          </a:fillRef>
-          <a:effectRef idx="2">
-            <a:schemeClr val="accent1"/>
-          </a:effectRef>
-          <a:fontRef idx="minor">
-            <a:schemeClr val="lt1"/>
-          </a:fontRef>
-        </p:style>
-        <p:txBody>
-          <a:bodyPr rtlCol="0" anchor="ctr" wrap="square" lIns="137160" rIns="137160"/>
-          <a:lstStyle/>
-          <a:p>
-            <a:pPr algn="l"/>
-            <a:r>
-              <a:rPr sz="1600">
-                <a:solidFill>
-                  <a:srgbClr val="C0392B"/>
-                </a:solidFill>
-                <a:latin typeface="Calibri"/>
-              </a:rPr>
-              <a:t>[Figure missing: fig2_class_balance.png — run the notebook]</a:t>
-            </a:r>
-          </a:p>
-        </p:txBody>
-      </p:sp>
+        </p:spPr>
+      </p:pic>
       <p:sp>
         <p:nvSpPr>
           <p:cNvPr id="9" name="TextBox 8"/>

</xml_diff>

<commit_message>
Q5: Kaggle data-leakage exercise completed; add evidence screenshots to slides
Co-Authored-By: Claude Opus 5.5 <noreply@anthropic.com>
Claude-Session: https://claude.ai/code/session_01Dodtt6SYgFo6Peocx728t9
</commit_message>
<xml_diff>
--- a/Presentation/ICT304_Tutorial3_Group4_DRAFT.pptx
+++ b/Presentation/ICT304_Tutorial3_Group4_DRAFT.pptx
@@ -1512,7 +1512,7 @@
           <a:lstStyle/>
           <a:p>
             <a:r>
-              <a:t>Use the numbers from the tutorial run. The drop from 98% to 83% looks bad but the 83% is the honest number. Add a screenshot of your own completed Kaggle tutorial/exercise here.</a:t>
+              <a:t>The drop from 98% to 83% looks bad but the 83% is the honest number. Exercise answers: shoelaces - leather used is leakage if only known during the month; housing - feature 2 (neighbourhood average price) is the leak because it can be updated with the house's own sale price.</a:t>
             </a:r>
           </a:p>
         </p:txBody>
@@ -16544,59 +16544,85 @@
           </a:graphicData>
         </a:graphic>
       </p:graphicFrame>
-      <p:sp>
-        <p:nvSpPr>
-          <p:cNvPr id="8" name="Rounded Rectangle 7"/>
-          <p:cNvSpPr/>
+      <p:pic>
+        <p:nvPicPr>
+          <p:cNvPr id="8" name="Picture 7" descr="q5_kaggle_exercise_correct.png"/>
+          <p:cNvPicPr>
+            <a:picLocks noChangeAspect="1"/>
+          </p:cNvPicPr>
           <p:nvPr/>
-        </p:nvSpPr>
-        <p:spPr>
-          <a:xfrm>
-            <a:off x="7589520" y="1280160"/>
-            <a:ext cx="4206240" cy="4206240"/>
-          </a:xfrm>
-          <a:prstGeom prst="roundRect">
-            <a:avLst>
-              <a:gd name="adj" fmla="val 8000"/>
-            </a:avLst>
+        </p:nvPicPr>
+        <p:blipFill>
+          <a:blip r:embed="rId3"/>
+          <a:stretch>
+            <a:fillRect/>
+          </a:stretch>
+        </p:blipFill>
+        <p:spPr>
+          <a:xfrm>
+            <a:off x="7772400" y="1188720"/>
+            <a:ext cx="3840480" cy="2600960"/>
+          </a:xfrm>
+          <a:prstGeom prst="rect">
+            <a:avLst/>
           </a:prstGeom>
-          <a:solidFill>
-            <a:srgbClr val="FDEDEC"/>
-          </a:solidFill>
-          <a:ln>
-            <a:solidFill>
-              <a:srgbClr val="2E86C1"/>
-            </a:solidFill>
-          </a:ln>
-        </p:spPr>
-        <p:style>
-          <a:lnRef idx="1">
-            <a:schemeClr val="accent1"/>
-          </a:lnRef>
-          <a:fillRef idx="3">
-            <a:schemeClr val="accent1"/>
-          </a:fillRef>
-          <a:effectRef idx="2">
-            <a:schemeClr val="accent1"/>
-          </a:effectRef>
-          <a:fontRef idx="minor">
-            <a:schemeClr val="lt1"/>
-          </a:fontRef>
-        </p:style>
-        <p:txBody>
-          <a:bodyPr rtlCol="0" anchor="ctr" wrap="square" lIns="137160" rIns="137160"/>
+        </p:spPr>
+      </p:pic>
+      <p:pic>
+        <p:nvPicPr>
+          <p:cNvPr id="9" name="Picture 8" descr="q5_kaggle_course_complete.png"/>
+          <p:cNvPicPr>
+            <a:picLocks noChangeAspect="1"/>
+          </p:cNvPicPr>
+          <p:nvPr/>
+        </p:nvPicPr>
+        <p:blipFill>
+          <a:blip r:embed="rId4"/>
+          <a:stretch>
+            <a:fillRect/>
+          </a:stretch>
+        </p:blipFill>
+        <p:spPr>
+          <a:xfrm>
+            <a:off x="7589520" y="4206240"/>
+            <a:ext cx="4206240" cy="1573948"/>
+          </a:xfrm>
+          <a:prstGeom prst="rect">
+            <a:avLst/>
+          </a:prstGeom>
+        </p:spPr>
+      </p:pic>
+      <p:sp>
+        <p:nvSpPr>
+          <p:cNvPr id="10" name="TextBox 9"/>
+          <p:cNvSpPr txBox="1"/>
+          <p:nvPr/>
+        </p:nvSpPr>
+        <p:spPr>
+          <a:xfrm>
+            <a:off x="7589520" y="5806440"/>
+            <a:ext cx="4206240" cy="457200"/>
+          </a:xfrm>
+          <a:prstGeom prst="rect">
+            <a:avLst/>
+          </a:prstGeom>
+          <a:noFill/>
+        </p:spPr>
+        <p:txBody>
+          <a:bodyPr wrap="square" anchor="t" lIns="45720" rIns="45720">
+            <a:spAutoFit/>
+          </a:bodyPr>
           <a:lstStyle/>
           <a:p>
             <a:pPr algn="l"/>
             <a:r>
-              <a:rPr sz="1400">
-                <a:solidFill>
-                  <a:srgbClr val="C0392B"/>
-                </a:solidFill>
-                <a:latin typeface="Calibri"/>
-              </a:rPr>
-              <a:t>[Insert screenshot of your completed Kaggle tutorial / exercise here]
-Source: Cook, A. — Kaggle Learn, Intermediate Machine Learning, "Data Leakage".</a:t>
+              <a:rPr sz="1000" b="0">
+                <a:solidFill>
+                  <a:srgbClr val="5D6D7E"/>
+                </a:solidFill>
+                <a:latin typeface="Calibri"/>
+              </a:rPr>
+              <a:t>Our completed Kaggle exercise (all 5 steps correct) and lesson 7 ticked. Source: Cook, A. — Kaggle Learn, Intermediate ML.</a:t>
             </a:r>
           </a:p>
         </p:txBody>

</xml_diff>